<commit_message>
feat: update poster with link
</commit_message>
<xml_diff>
--- a/poster_final.pptx
+++ b/poster_final.pptx
@@ -251,7 +251,7 @@
           <a:p>
             <a:fld id="{60BC2A36-4833-4F94-98C9-9A04AFB66017}" type="datetimeFigureOut">
               <a:rPr lang="en-GB" smtClean="0"/>
-              <a:t>27/02/2026</a:t>
+              <a:t>04/03/2026</a:t>
             </a:fld>
             <a:endParaRPr lang="en-GB"/>
           </a:p>
@@ -421,7 +421,7 @@
           <a:p>
             <a:fld id="{60BC2A36-4833-4F94-98C9-9A04AFB66017}" type="datetimeFigureOut">
               <a:rPr lang="en-GB" smtClean="0"/>
-              <a:t>27/02/2026</a:t>
+              <a:t>04/03/2026</a:t>
             </a:fld>
             <a:endParaRPr lang="en-GB"/>
           </a:p>
@@ -601,7 +601,7 @@
           <a:p>
             <a:fld id="{60BC2A36-4833-4F94-98C9-9A04AFB66017}" type="datetimeFigureOut">
               <a:rPr lang="en-GB" smtClean="0"/>
-              <a:t>27/02/2026</a:t>
+              <a:t>04/03/2026</a:t>
             </a:fld>
             <a:endParaRPr lang="en-GB"/>
           </a:p>
@@ -771,7 +771,7 @@
           <a:p>
             <a:fld id="{60BC2A36-4833-4F94-98C9-9A04AFB66017}" type="datetimeFigureOut">
               <a:rPr lang="en-GB" smtClean="0"/>
-              <a:t>27/02/2026</a:t>
+              <a:t>04/03/2026</a:t>
             </a:fld>
             <a:endParaRPr lang="en-GB"/>
           </a:p>
@@ -1017,7 +1017,7 @@
           <a:p>
             <a:fld id="{60BC2A36-4833-4F94-98C9-9A04AFB66017}" type="datetimeFigureOut">
               <a:rPr lang="en-GB" smtClean="0"/>
-              <a:t>27/02/2026</a:t>
+              <a:t>04/03/2026</a:t>
             </a:fld>
             <a:endParaRPr lang="en-GB"/>
           </a:p>
@@ -1249,7 +1249,7 @@
           <a:p>
             <a:fld id="{60BC2A36-4833-4F94-98C9-9A04AFB66017}" type="datetimeFigureOut">
               <a:rPr lang="en-GB" smtClean="0"/>
-              <a:t>27/02/2026</a:t>
+              <a:t>04/03/2026</a:t>
             </a:fld>
             <a:endParaRPr lang="en-GB"/>
           </a:p>
@@ -1616,7 +1616,7 @@
           <a:p>
             <a:fld id="{60BC2A36-4833-4F94-98C9-9A04AFB66017}" type="datetimeFigureOut">
               <a:rPr lang="en-GB" smtClean="0"/>
-              <a:t>27/02/2026</a:t>
+              <a:t>04/03/2026</a:t>
             </a:fld>
             <a:endParaRPr lang="en-GB"/>
           </a:p>
@@ -1734,7 +1734,7 @@
           <a:p>
             <a:fld id="{60BC2A36-4833-4F94-98C9-9A04AFB66017}" type="datetimeFigureOut">
               <a:rPr lang="en-GB" smtClean="0"/>
-              <a:t>27/02/2026</a:t>
+              <a:t>04/03/2026</a:t>
             </a:fld>
             <a:endParaRPr lang="en-GB"/>
           </a:p>
@@ -1829,7 +1829,7 @@
           <a:p>
             <a:fld id="{60BC2A36-4833-4F94-98C9-9A04AFB66017}" type="datetimeFigureOut">
               <a:rPr lang="en-GB" smtClean="0"/>
-              <a:t>27/02/2026</a:t>
+              <a:t>04/03/2026</a:t>
             </a:fld>
             <a:endParaRPr lang="en-GB"/>
           </a:p>
@@ -2106,7 +2106,7 @@
           <a:p>
             <a:fld id="{60BC2A36-4833-4F94-98C9-9A04AFB66017}" type="datetimeFigureOut">
               <a:rPr lang="en-GB" smtClean="0"/>
-              <a:t>27/02/2026</a:t>
+              <a:t>04/03/2026</a:t>
             </a:fld>
             <a:endParaRPr lang="en-GB"/>
           </a:p>
@@ -2363,7 +2363,7 @@
           <a:p>
             <a:fld id="{60BC2A36-4833-4F94-98C9-9A04AFB66017}" type="datetimeFigureOut">
               <a:rPr lang="en-GB" smtClean="0"/>
-              <a:t>27/02/2026</a:t>
+              <a:t>04/03/2026</a:t>
             </a:fld>
             <a:endParaRPr lang="en-GB"/>
           </a:p>
@@ -2576,7 +2576,7 @@
           <a:p>
             <a:fld id="{60BC2A36-4833-4F94-98C9-9A04AFB66017}" type="datetimeFigureOut">
               <a:rPr lang="en-GB" smtClean="0"/>
-              <a:t>27/02/2026</a:t>
+              <a:t>04/03/2026</a:t>
             </a:fld>
             <a:endParaRPr lang="en-GB"/>
           </a:p>
@@ -3642,8 +3642,8 @@
         </p:nvSpPr>
         <p:spPr>
           <a:xfrm>
-            <a:off x="612943" y="5134854"/>
-            <a:ext cx="9723495" cy="5390185"/>
+            <a:off x="612497" y="4932882"/>
+            <a:ext cx="9765951" cy="5632311"/>
           </a:xfrm>
           <a:prstGeom prst="rect">
             <a:avLst/>
@@ -3667,23 +3667,7 @@
           <a:p>
             <a:r>
               <a:rPr lang="en-GB" sz="2400" dirty="0"/>
-              <a:t>Nonetheless, </a:t>
-            </a:r>
-            <a:r>
-              <a:rPr lang="en-GB" sz="2400" err="1"/>
-              <a:t>th</a:t>
-            </a:r>
-            <a:r>
-              <a:rPr lang="en-GB" sz="2400" dirty="0"/>
-              <a:t>is is still an emerging field and still has shortcomings that need to be addressed. One such problem is the focus on single-model images. While these models can excel at images with only a single subject, they struggle to generalise to multiple subjects, leading to complete failure of </a:t>
-            </a:r>
-            <a:r>
-              <a:rPr lang="en-GB" sz="2400"/>
-              <a:t>the models. This motivates our model for multi-subject </a:t>
-            </a:r>
-            <a:r>
-              <a:rPr lang="en-GB" sz="2400" dirty="0"/>
-              <a:t>VTON.</a:t>
+              <a:t>Nonetheless, this is still an emerging field and still has shortcomings that need to be addressed. One such problem is the focus on single-model images. While these models can excel at images with only a single subject, they struggle to generalise to multiple subjects, leading to complete failure of the models. This motivates our model for multi-subject VTON. Our demo is available at: https://huggingface.co/spaces/mvp-lab/VTON_TEST</a:t>
             </a:r>
           </a:p>
         </p:txBody>
@@ -3702,7 +3686,7 @@
         </p:nvGrpSpPr>
         <p:grpSpPr>
           <a:xfrm>
-            <a:off x="10955828" y="17381168"/>
+            <a:off x="10984812" y="17392942"/>
             <a:ext cx="9990325" cy="8091043"/>
             <a:chOff x="566057" y="3657600"/>
             <a:chExt cx="9056914" cy="6662057"/>
@@ -3823,7 +3807,7 @@
         <p:spPr>
           <a:xfrm>
             <a:off x="612943" y="11888139"/>
-            <a:ext cx="9723495" cy="12187952"/>
+            <a:ext cx="9723495" cy="11449288"/>
           </a:xfrm>
           <a:prstGeom prst="rect">
             <a:avLst/>
@@ -3907,9 +3891,6 @@
             <a:endParaRPr lang="en-GB" sz="2400" dirty="0"/>
           </a:p>
           <a:p>
-            <a:endParaRPr lang="en-GB" sz="2400" dirty="0"/>
-          </a:p>
-          <a:p>
             <a:r>
               <a:rPr lang="en-GB" sz="2400" dirty="0"/>
               <a:t>The people are first segmented by the YOLO v8 model, and the masks are used to separate each subject to their own image with a blank background. FASHN VTON v1.5 is run separately for each image, generating images of the people with the specified clothing. The images are processed at intersection boundaries to prevent the blank background leaking. The order of the subjects is then estimated heuristically based on the concavity or convexity of overlaps, and they are recomposed into the original image back-to-front to properly handle occlusion.</a:t>
@@ -4114,7 +4095,7 @@
         </p:nvSpPr>
         <p:spPr>
           <a:xfrm>
-            <a:off x="612497" y="14050313"/>
+            <a:off x="612943" y="13747221"/>
             <a:ext cx="9723495" cy="1107996"/>
           </a:xfrm>
           <a:prstGeom prst="rect">
@@ -4130,60 +4111,15 @@
           <a:p>
             <a:pPr algn="ctr"/>
             <a:r>
-              <a:rPr lang="en-GB" sz="2400" b="1" u="sng"/>
+              <a:rPr lang="en-GB" sz="2400" b="1" u="sng" dirty="0"/>
               <a:t>Inference Pipeline</a:t>
             </a:r>
-            <a:endParaRPr lang="en-GB" sz="2400" b="1" u="sng" dirty="0"/>
           </a:p>
           <a:p>
             <a:endParaRPr lang="en-GB" sz="2400" dirty="0"/>
           </a:p>
           <a:p>
             <a:endParaRPr lang="en-GB" dirty="0"/>
-          </a:p>
-        </p:txBody>
-      </p:sp>
-      <p:sp>
-        <p:nvSpPr>
-          <p:cNvPr id="13" name="TextBox 12">
-            <a:extLst>
-              <a:ext uri="{FF2B5EF4-FFF2-40B4-BE49-F238E27FC236}">
-                <a16:creationId xmlns:a16="http://schemas.microsoft.com/office/drawing/2014/main" id="{3AA79636-22EC-CDA2-4971-FC14D6D29E94}"/>
-              </a:ext>
-            </a:extLst>
-          </p:cNvPr>
-          <p:cNvSpPr txBox="1"/>
-          <p:nvPr/>
-        </p:nvSpPr>
-        <p:spPr>
-          <a:xfrm>
-            <a:off x="11090522" y="9755972"/>
-            <a:ext cx="9723495" cy="2677656"/>
-          </a:xfrm>
-          <a:prstGeom prst="rect">
-            <a:avLst/>
-          </a:prstGeom>
-          <a:noFill/>
-        </p:spPr>
-        <p:txBody>
-          <a:bodyPr wrap="square" lIns="91440" tIns="45720" rIns="91440" bIns="45720" rtlCol="0" anchor="t">
-            <a:spAutoFit/>
-          </a:bodyPr>
-          <a:lstStyle/>
-          <a:p>
-            <a:r>
-              <a:rPr lang="en-GB" sz="2400" dirty="0"/>
-              <a:t>From the above input photos, the original pipeline produced the image on the left. Only one subject has his clothing swapped, and the surrounding people are corrupted by this process.</a:t>
-            </a:r>
-          </a:p>
-          <a:p>
-            <a:endParaRPr lang="en-GB" sz="2400" dirty="0"/>
-          </a:p>
-          <a:p>
-            <a:r>
-              <a:rPr lang="en-GB" sz="2400" dirty="0"/>
-              <a:t>Our pipeline resolves these two issues, producing the image on the right. This successfully swaps the clothing for all 4 individuals while preventing the corruption in the original pipeline.</a:t>
-            </a:r>
           </a:p>
         </p:txBody>
       </p:sp>
@@ -4239,8 +4175,8 @@
         </p:blipFill>
         <p:spPr>
           <a:xfrm>
-            <a:off x="11821113" y="5084482"/>
-            <a:ext cx="4914199" cy="4627329"/>
+            <a:off x="11857080" y="4987791"/>
+            <a:ext cx="3953812" cy="3723005"/>
           </a:xfrm>
           <a:prstGeom prst="rect">
             <a:avLst/>
@@ -4269,8 +4205,8 @@
         </p:blipFill>
         <p:spPr>
           <a:xfrm>
-            <a:off x="17101119" y="5073556"/>
-            <a:ext cx="3135013" cy="4649139"/>
+            <a:off x="17101120" y="5073557"/>
+            <a:ext cx="2452668" cy="3637240"/>
           </a:xfrm>
           <a:prstGeom prst="rect">
             <a:avLst/>
@@ -4319,11 +4255,7 @@
             </a:pPr>
             <a:r>
               <a:rPr lang="en-GB" sz="2400" dirty="0"/>
-              <a:t>Firstly, the technique we apply here relies on an ordering of subjects to exist (i.e. back to font), however this assumption breaks down when they overlap, for example when linking arms. Such an image would require the model to either preserve the linked arm, or process both subjects in one pass, something the current model is i</a:t>
-            </a:r>
-            <a:r>
-              <a:rPr lang="en-GB" sz="2400"/>
-              <a:t>ncapable of.</a:t>
+              <a:t>Firstly, the technique we apply here relies on an ordering of subjects to exist (i.e. back to font), however this assumption breaks down when they overlap, for example when linking arms. Such an image would require the model to either preserve the linked arm, or process both subjects in one pass, something the current model is incapable of.</a:t>
             </a:r>
           </a:p>
           <a:p>
@@ -4338,11 +4270,7 @@
             </a:pPr>
             <a:r>
               <a:rPr lang="en-GB" sz="2400" dirty="0"/>
-              <a:t>Secondly, this method does not work if a subject is extremely occluded. While the FASHN VTON v1.5 model can handle some occlusion of body parts, such as parts of the arms, when too much of the subject is occluded, it does not know how to correctly predict the pose or </a:t>
-            </a:r>
-            <a:r>
-              <a:rPr lang="en-GB" sz="2400"/>
-              <a:t>extrapolate body parts, leading to incorrect generation of clothing.</a:t>
+              <a:t>Secondly, this method does not work if a subject is extremely occluded. While the FASHN VTON v1.5 model can handle some occlusion of body parts, such as parts of the arms, when too much of the subject is occluded, it does not know how to correctly predict the pose or extrapolate body parts, leading to incorrect generation of clothing.</a:t>
             </a:r>
           </a:p>
           <a:p>
@@ -4523,12 +4451,52 @@
           </a:p>
         </p:txBody>
       </p:sp>
+      <p:sp>
+        <p:nvSpPr>
+          <p:cNvPr id="2" name="TextBox 1">
+            <a:extLst>
+              <a:ext uri="{FF2B5EF4-FFF2-40B4-BE49-F238E27FC236}">
+                <a16:creationId xmlns:a16="http://schemas.microsoft.com/office/drawing/2014/main" id="{39F3B9FF-84DE-965D-9754-1F471B7D7F34}"/>
+              </a:ext>
+            </a:extLst>
+          </p:cNvPr>
+          <p:cNvSpPr txBox="1"/>
+          <p:nvPr/>
+        </p:nvSpPr>
+        <p:spPr>
+          <a:xfrm>
+            <a:off x="3896198" y="19208084"/>
+            <a:ext cx="3128716" cy="369332"/>
+          </a:xfrm>
+          <a:prstGeom prst="rect">
+            <a:avLst/>
+          </a:prstGeom>
+          <a:noFill/>
+        </p:spPr>
+        <p:txBody>
+          <a:bodyPr wrap="square" rtlCol="0">
+            <a:spAutoFit/>
+          </a:bodyPr>
+          <a:lstStyle/>
+          <a:p>
+            <a:r>
+              <a:rPr lang="en-GB" dirty="0"/>
+              <a:t>Remove subjects and </a:t>
+            </a:r>
+            <a:r>
+              <a:rPr lang="en-GB" dirty="0" err="1"/>
+              <a:t>inpaint</a:t>
+            </a:r>
+            <a:endParaRPr lang="en-GB" dirty="0"/>
+          </a:p>
+        </p:txBody>
+      </p:sp>
       <p:pic>
         <p:nvPicPr>
-          <p:cNvPr id="32" name="Picture 31" descr="A group of men in black shirts&#10;&#10;AI-generated content may be incorrect.">
+          <p:cNvPr id="31" name="Picture 30">
             <a:extLst>
               <a:ext uri="{FF2B5EF4-FFF2-40B4-BE49-F238E27FC236}">
-                <a16:creationId xmlns:a16="http://schemas.microsoft.com/office/drawing/2014/main" id="{96A3F3EE-C269-671C-9FDE-2C66FC10471B}"/>
+                <a16:creationId xmlns:a16="http://schemas.microsoft.com/office/drawing/2014/main" id="{A56EA178-52D2-CC0C-0318-346557F1D0B7}"/>
               </a:ext>
             </a:extLst>
           </p:cNvPr>
@@ -4539,15 +4507,14 @@
         </p:nvPicPr>
         <p:blipFill>
           <a:blip r:embed="rId8"/>
-          <a:srcRect t="42" b="381"/>
           <a:stretch>
             <a:fillRect/>
           </a:stretch>
         </p:blipFill>
         <p:spPr>
           <a:xfrm>
-            <a:off x="15985135" y="12384862"/>
-            <a:ext cx="4793624" cy="4478655"/>
+            <a:off x="1049865" y="14415709"/>
+            <a:ext cx="8821381" cy="4906060"/>
           </a:xfrm>
           <a:prstGeom prst="rect">
             <a:avLst/>
@@ -4556,10 +4523,10 @@
       </p:pic>
       <p:pic>
         <p:nvPicPr>
-          <p:cNvPr id="39" name="Picture 38" descr="A diagram of a person&#10;&#10;AI-generated content may be incorrect.">
+          <p:cNvPr id="33" name="Picture 32">
             <a:extLst>
               <a:ext uri="{FF2B5EF4-FFF2-40B4-BE49-F238E27FC236}">
-                <a16:creationId xmlns:a16="http://schemas.microsoft.com/office/drawing/2014/main" id="{64B05A8A-5D2A-26A2-D0FE-97F273DB8F2C}"/>
+                <a16:creationId xmlns:a16="http://schemas.microsoft.com/office/drawing/2014/main" id="{5A3F611C-3C01-ED79-08E9-B8827F6227D1}"/>
               </a:ext>
             </a:extLst>
           </p:cNvPr>
@@ -4569,21 +4536,81 @@
           <p:nvPr/>
         </p:nvPicPr>
         <p:blipFill>
-          <a:blip r:embed="rId9"/>
+          <a:blip r:embed="rId9">
+            <a:extLst>
+              <a:ext uri="{28A0092B-C50C-407E-A947-70E740481C1C}">
+                <a14:useLocalDpi xmlns:a14="http://schemas.microsoft.com/office/drawing/2010/main" val="0"/>
+              </a:ext>
+            </a:extLst>
+          </a:blip>
+          <a:srcRect l="9035" t="6100" r="6860" b="5850"/>
           <a:stretch>
             <a:fillRect/>
           </a:stretch>
         </p:blipFill>
         <p:spPr>
           <a:xfrm>
-            <a:off x="748362" y="14494652"/>
-            <a:ext cx="9379318" cy="5185710"/>
+            <a:off x="15966955" y="12272563"/>
+            <a:ext cx="4943004" cy="4572918"/>
           </a:xfrm>
           <a:prstGeom prst="rect">
             <a:avLst/>
           </a:prstGeom>
         </p:spPr>
       </p:pic>
+      <p:sp>
+        <p:nvSpPr>
+          <p:cNvPr id="13" name="TextBox 12">
+            <a:extLst>
+              <a:ext uri="{FF2B5EF4-FFF2-40B4-BE49-F238E27FC236}">
+                <a16:creationId xmlns:a16="http://schemas.microsoft.com/office/drawing/2014/main" id="{3AA79636-22EC-CDA2-4971-FC14D6D29E94}"/>
+              </a:ext>
+            </a:extLst>
+          </p:cNvPr>
+          <p:cNvSpPr txBox="1"/>
+          <p:nvPr/>
+        </p:nvSpPr>
+        <p:spPr>
+          <a:xfrm>
+            <a:off x="11251642" y="8641899"/>
+            <a:ext cx="9723495" cy="3785652"/>
+          </a:xfrm>
+          <a:prstGeom prst="rect">
+            <a:avLst/>
+          </a:prstGeom>
+          <a:noFill/>
+        </p:spPr>
+        <p:txBody>
+          <a:bodyPr wrap="square" lIns="91440" tIns="45720" rIns="91440" bIns="45720" rtlCol="0" anchor="t">
+            <a:spAutoFit/>
+          </a:bodyPr>
+          <a:lstStyle/>
+          <a:p>
+            <a:r>
+              <a:rPr lang="en-GB" sz="2400" dirty="0"/>
+              <a:t>From the above input photos, the original pipeline produced the image on the left. Only one subject has his clothing swapped, and the surrounding people are corrupted by this process.</a:t>
+            </a:r>
+          </a:p>
+          <a:p>
+            <a:endParaRPr lang="en-GB" sz="2400" dirty="0"/>
+          </a:p>
+          <a:p>
+            <a:r>
+              <a:rPr lang="en-GB" sz="2400" dirty="0"/>
+              <a:t>Our pipeline resolves these two issues, producing the image on the right. This successfully swaps the clothing for all 4 individuals while preventing the corruption in the original pipeline. However, some artifacts appear.</a:t>
+            </a:r>
+          </a:p>
+          <a:p>
+            <a:endParaRPr lang="en-GB" sz="2400" dirty="0"/>
+          </a:p>
+          <a:p>
+            <a:r>
+              <a:rPr lang="en-GB" sz="2400" dirty="0"/>
+              <a:t>For example, the man on the left’s arms are incorrectly rendered. This is due to the segmentation model incorrectly removing part of his arm.</a:t>
+            </a:r>
+          </a:p>
+        </p:txBody>
+      </p:sp>
     </p:spTree>
     <p:extLst>
       <p:ext uri="{BB962C8B-B14F-4D97-AF65-F5344CB8AC3E}">

</xml_diff>